<commit_message>
Cambios en Presentacion y en Power BI
</commit_message>
<xml_diff>
--- a/Reto_Final/Presentación/Presentacion-Practicum.pptx
+++ b/Reto_Final/Presentación/Presentacion-Practicum.pptx
@@ -5,7 +5,7 @@
     <p:sldMasterId id="2147483648" r:id="rId1"/>
   </p:sldMasterIdLst>
   <p:notesMasterIdLst>
-    <p:notesMasterId r:id="rId13"/>
+    <p:notesMasterId r:id="rId14"/>
   </p:notesMasterIdLst>
   <p:sldIdLst>
     <p:sldId id="256" r:id="rId2"/>
@@ -18,7 +18,8 @@
     <p:sldId id="263" r:id="rId9"/>
     <p:sldId id="264" r:id="rId10"/>
     <p:sldId id="265" r:id="rId11"/>
-    <p:sldId id="266" r:id="rId12"/>
+    <p:sldId id="267" r:id="rId12"/>
+    <p:sldId id="266" r:id="rId13"/>
   </p:sldIdLst>
   <p:sldSz cx="12192000" cy="6858000"/>
   <p:notesSz cx="6858000" cy="9144000"/>
@@ -4408,6 +4409,568 @@
 </file>
 
 <file path=ppt/slides/slide11.xml><?xml version="1.0" encoding="utf-8"?>
+<p:sld xmlns:a="http://schemas.openxmlformats.org/drawingml/2006/main" xmlns:r="http://schemas.openxmlformats.org/officeDocument/2006/relationships" xmlns:p="http://schemas.openxmlformats.org/presentationml/2006/main">
+  <p:cSld>
+    <p:spTree>
+      <p:nvGrpSpPr>
+        <p:cNvPr id="1" name=""/>
+        <p:cNvGrpSpPr/>
+        <p:nvPr/>
+      </p:nvGrpSpPr>
+      <p:grpSpPr>
+        <a:xfrm>
+          <a:off x="0" y="0"/>
+          <a:ext cx="0" cy="0"/>
+          <a:chOff x="0" y="0"/>
+          <a:chExt cx="0" cy="0"/>
+        </a:xfrm>
+      </p:grpSpPr>
+      <p:pic>
+        <p:nvPicPr>
+          <p:cNvPr id="2" name="Picture 1" descr="image.png"/>
+          <p:cNvPicPr>
+            <a:picLocks noChangeAspect="1"/>
+          </p:cNvPicPr>
+          <p:nvPr/>
+        </p:nvPicPr>
+        <p:blipFill>
+          <a:blip r:embed="rId2"/>
+          <a:stretch>
+            <a:fillRect/>
+          </a:stretch>
+        </p:blipFill>
+        <p:spPr>
+          <a:xfrm>
+            <a:off x="0" y="0"/>
+            <a:ext cx="12192000" cy="6858000"/>
+          </a:xfrm>
+          <a:prstGeom prst="rect">
+            <a:avLst/>
+          </a:prstGeom>
+        </p:spPr>
+      </p:pic>
+      <p:pic>
+        <p:nvPicPr>
+          <p:cNvPr id="3" name="Picture 2" descr="image.png"/>
+          <p:cNvPicPr>
+            <a:picLocks noChangeAspect="1"/>
+          </p:cNvPicPr>
+          <p:nvPr/>
+        </p:nvPicPr>
+        <p:blipFill>
+          <a:blip r:embed="rId3"/>
+          <a:stretch>
+            <a:fillRect/>
+          </a:stretch>
+        </p:blipFill>
+        <p:spPr>
+          <a:xfrm>
+            <a:off x="11012388" y="76200"/>
+            <a:ext cx="1103411" cy="180975"/>
+          </a:xfrm>
+          <a:prstGeom prst="rect">
+            <a:avLst/>
+          </a:prstGeom>
+        </p:spPr>
+      </p:pic>
+      <p:pic>
+        <p:nvPicPr>
+          <p:cNvPr id="4" name="Picture 3" descr="image.png"/>
+          <p:cNvPicPr>
+            <a:picLocks noChangeAspect="1"/>
+          </p:cNvPicPr>
+          <p:nvPr/>
+        </p:nvPicPr>
+        <p:blipFill>
+          <a:blip r:embed="rId4"/>
+          <a:stretch>
+            <a:fillRect/>
+          </a:stretch>
+        </p:blipFill>
+        <p:spPr>
+          <a:xfrm>
+            <a:off x="571500" y="2265015"/>
+            <a:ext cx="3555950" cy="3600450"/>
+          </a:xfrm>
+          <a:prstGeom prst="rect">
+            <a:avLst/>
+          </a:prstGeom>
+        </p:spPr>
+      </p:pic>
+      <p:pic>
+        <p:nvPicPr>
+          <p:cNvPr id="5" name="Picture 4" descr="image.png"/>
+          <p:cNvPicPr>
+            <a:picLocks noChangeAspect="1"/>
+          </p:cNvPicPr>
+          <p:nvPr/>
+        </p:nvPicPr>
+        <p:blipFill>
+          <a:blip r:embed="rId5"/>
+          <a:stretch>
+            <a:fillRect/>
+          </a:stretch>
+        </p:blipFill>
+        <p:spPr>
+          <a:xfrm>
+            <a:off x="4317950" y="2265015"/>
+            <a:ext cx="3555950" cy="3600450"/>
+          </a:xfrm>
+          <a:prstGeom prst="rect">
+            <a:avLst/>
+          </a:prstGeom>
+        </p:spPr>
+      </p:pic>
+      <p:pic>
+        <p:nvPicPr>
+          <p:cNvPr id="6" name="Picture 5" descr="image.png"/>
+          <p:cNvPicPr>
+            <a:picLocks noChangeAspect="1"/>
+          </p:cNvPicPr>
+          <p:nvPr/>
+        </p:nvPicPr>
+        <p:blipFill>
+          <a:blip r:embed="rId6"/>
+          <a:stretch>
+            <a:fillRect/>
+          </a:stretch>
+        </p:blipFill>
+        <p:spPr>
+          <a:xfrm>
+            <a:off x="8064400" y="2265015"/>
+            <a:ext cx="3555950" cy="3600450"/>
+          </a:xfrm>
+          <a:prstGeom prst="rect">
+            <a:avLst/>
+          </a:prstGeom>
+        </p:spPr>
+      </p:pic>
+      <p:sp>
+        <p:nvSpPr>
+          <p:cNvPr id="7" name="TextBox 6"/>
+          <p:cNvSpPr txBox="1"/>
+          <p:nvPr/>
+        </p:nvSpPr>
+        <p:spPr>
+          <a:xfrm>
+            <a:off x="866775" y="3303240"/>
+            <a:ext cx="3113670" cy="257175"/>
+          </a:xfrm>
+          <a:prstGeom prst="rect">
+            <a:avLst/>
+          </a:prstGeom>
+          <a:noFill/>
+        </p:spPr>
+        <p:txBody>
+          <a:bodyPr wrap="square" lIns="0" tIns="0" rIns="0" bIns="0" anchor="t">
+            <a:spAutoFit/>
+          </a:bodyPr>
+          <a:lstStyle/>
+          <a:p>
+            <a:pPr algn="l"/>
+            <a:r>
+              <a:rPr sz="1650" b="1" i="0" u="none">
+                <a:solidFill>
+                  <a:srgbClr val="F8FAFC"/>
+                </a:solidFill>
+                <a:latin typeface="Montserrat"/>
+              </a:rPr>
+              <a:t>1. IA Predictiva</a:t>
+            </a:r>
+          </a:p>
+        </p:txBody>
+      </p:sp>
+      <p:sp>
+        <p:nvSpPr>
+          <p:cNvPr id="8" name="TextBox 7"/>
+          <p:cNvSpPr txBox="1"/>
+          <p:nvPr/>
+        </p:nvSpPr>
+        <p:spPr>
+          <a:xfrm>
+            <a:off x="866775" y="3798540"/>
+            <a:ext cx="2965400" cy="1371600"/>
+          </a:xfrm>
+          <a:prstGeom prst="rect">
+            <a:avLst/>
+          </a:prstGeom>
+          <a:noFill/>
+        </p:spPr>
+        <p:txBody>
+          <a:bodyPr wrap="square" lIns="0" tIns="0" rIns="0" bIns="0" anchor="t">
+            <a:spAutoFit/>
+          </a:bodyPr>
+          <a:lstStyle/>
+          <a:p>
+            <a:pPr algn="l">
+              <a:lnSpc>
+                <a:spcPts val="1800"/>
+              </a:lnSpc>
+            </a:pPr>
+            <a:r>
+              <a:rPr sz="1200" b="0" i="0" u="none">
+                <a:solidFill>
+                  <a:srgbClr val="CBD5E1"/>
+                </a:solidFill>
+                <a:latin typeface="Open Sans"/>
+              </a:rPr>
+              <a:t>Con una Capa Gold limpia e histórica, el siguiente paso es aplicar modelos de Machine Learning. Debemos pasar de un análisis descriptivo (¿qué pasó?) a uno predictivo (¿qué carreras tendrán más demanda futura?).</a:t>
+            </a:r>
+          </a:p>
+        </p:txBody>
+      </p:sp>
+      <p:sp>
+        <p:nvSpPr>
+          <p:cNvPr id="9" name="TextBox 8"/>
+          <p:cNvSpPr txBox="1"/>
+          <p:nvPr/>
+        </p:nvSpPr>
+        <p:spPr>
+          <a:xfrm>
+            <a:off x="4613225" y="3303240"/>
+            <a:ext cx="3113670" cy="514350"/>
+          </a:xfrm>
+          <a:prstGeom prst="rect">
+            <a:avLst/>
+          </a:prstGeom>
+          <a:noFill/>
+        </p:spPr>
+        <p:txBody>
+          <a:bodyPr wrap="square" lIns="0" tIns="0" rIns="0" bIns="0" anchor="t">
+            <a:spAutoFit/>
+          </a:bodyPr>
+          <a:lstStyle/>
+          <a:p>
+            <a:pPr algn="l"/>
+            <a:r>
+              <a:rPr sz="1650" b="1" i="0" u="none">
+                <a:solidFill>
+                  <a:srgbClr val="F8FAFC"/>
+                </a:solidFill>
+                <a:latin typeface="Montserrat"/>
+              </a:rPr>
+              <a:t>2. Automatización Proactiva</a:t>
+            </a:r>
+          </a:p>
+        </p:txBody>
+      </p:sp>
+      <p:sp>
+        <p:nvSpPr>
+          <p:cNvPr id="10" name="TextBox 9"/>
+          <p:cNvSpPr txBox="1"/>
+          <p:nvPr/>
+        </p:nvSpPr>
+        <p:spPr>
+          <a:xfrm>
+            <a:off x="4613225" y="4055715"/>
+            <a:ext cx="2965400" cy="1371600"/>
+          </a:xfrm>
+          <a:prstGeom prst="rect">
+            <a:avLst/>
+          </a:prstGeom>
+          <a:noFill/>
+        </p:spPr>
+        <p:txBody>
+          <a:bodyPr wrap="square" lIns="0" tIns="0" rIns="0" bIns="0" anchor="t">
+            <a:spAutoFit/>
+          </a:bodyPr>
+          <a:lstStyle/>
+          <a:p>
+            <a:pPr algn="l">
+              <a:lnSpc>
+                <a:spcPts val="1800"/>
+              </a:lnSpc>
+            </a:pPr>
+            <a:r>
+              <a:rPr sz="1200" b="0" i="0" u="none">
+                <a:solidFill>
+                  <a:srgbClr val="CBD5E1"/>
+                </a:solidFill>
+                <a:latin typeface="Open Sans"/>
+              </a:rPr>
+              <a:t>Evolucionar de un tablero pasivo a un sistema de alertas activas. Configurar notificaciones automáticas para las autoridades si un indicador estratégico (ej. brecha laboral) cruza un umbral crítico.</a:t>
+            </a:r>
+          </a:p>
+        </p:txBody>
+      </p:sp>
+      <p:sp>
+        <p:nvSpPr>
+          <p:cNvPr id="11" name="TextBox 10"/>
+          <p:cNvSpPr txBox="1"/>
+          <p:nvPr/>
+        </p:nvSpPr>
+        <p:spPr>
+          <a:xfrm>
+            <a:off x="8359675" y="3303240"/>
+            <a:ext cx="3113670" cy="257175"/>
+          </a:xfrm>
+          <a:prstGeom prst="rect">
+            <a:avLst/>
+          </a:prstGeom>
+          <a:noFill/>
+        </p:spPr>
+        <p:txBody>
+          <a:bodyPr wrap="square" lIns="0" tIns="0" rIns="0" bIns="0" anchor="t">
+            <a:spAutoFit/>
+          </a:bodyPr>
+          <a:lstStyle/>
+          <a:p>
+            <a:pPr algn="l"/>
+            <a:r>
+              <a:rPr sz="1650" b="1" i="0" u="none">
+                <a:solidFill>
+                  <a:srgbClr val="F8FAFC"/>
+                </a:solidFill>
+                <a:latin typeface="Montserrat"/>
+              </a:rPr>
+              <a:t>3. Escalabilidad Cloud</a:t>
+            </a:r>
+          </a:p>
+        </p:txBody>
+      </p:sp>
+      <p:sp>
+        <p:nvSpPr>
+          <p:cNvPr id="12" name="TextBox 11"/>
+          <p:cNvSpPr txBox="1"/>
+          <p:nvPr/>
+        </p:nvSpPr>
+        <p:spPr>
+          <a:xfrm>
+            <a:off x="8359675" y="3798540"/>
+            <a:ext cx="2965400" cy="1371600"/>
+          </a:xfrm>
+          <a:prstGeom prst="rect">
+            <a:avLst/>
+          </a:prstGeom>
+          <a:noFill/>
+        </p:spPr>
+        <p:txBody>
+          <a:bodyPr wrap="square" lIns="0" tIns="0" rIns="0" bIns="0" anchor="t">
+            <a:spAutoFit/>
+          </a:bodyPr>
+          <a:lstStyle/>
+          <a:p>
+            <a:pPr algn="l">
+              <a:lnSpc>
+                <a:spcPts val="1800"/>
+              </a:lnSpc>
+            </a:pPr>
+            <a:r>
+              <a:rPr sz="1200" b="0" i="0" u="none">
+                <a:solidFill>
+                  <a:srgbClr val="CBD5E1"/>
+                </a:solidFill>
+                <a:latin typeface="Open Sans"/>
+              </a:rPr>
+              <a:t>Migrar la base de datos local (SQLite) a un Data Warehouse en la nube (ej. Azure/AWS). Esto democratizará los datos, permitiendo que otras facultades consuman esta misma "única fuente de la verdad".</a:t>
+            </a:r>
+          </a:p>
+        </p:txBody>
+      </p:sp>
+      <p:pic>
+        <p:nvPicPr>
+          <p:cNvPr id="13" name="Picture 12" descr="image.png"/>
+          <p:cNvPicPr>
+            <a:picLocks noChangeAspect="1"/>
+          </p:cNvPicPr>
+          <p:nvPr/>
+        </p:nvPicPr>
+        <p:blipFill>
+          <a:blip r:embed="rId7"/>
+          <a:stretch>
+            <a:fillRect/>
+          </a:stretch>
+        </p:blipFill>
+        <p:spPr>
+          <a:xfrm>
+            <a:off x="866775" y="2665065"/>
+            <a:ext cx="381000" cy="381000"/>
+          </a:xfrm>
+          <a:prstGeom prst="rect">
+            <a:avLst/>
+          </a:prstGeom>
+        </p:spPr>
+      </p:pic>
+      <p:pic>
+        <p:nvPicPr>
+          <p:cNvPr id="14" name="Picture 13" descr="image.png"/>
+          <p:cNvPicPr>
+            <a:picLocks noChangeAspect="1"/>
+          </p:cNvPicPr>
+          <p:nvPr/>
+        </p:nvPicPr>
+        <p:blipFill>
+          <a:blip r:embed="rId8"/>
+          <a:stretch>
+            <a:fillRect/>
+          </a:stretch>
+        </p:blipFill>
+        <p:spPr>
+          <a:xfrm>
+            <a:off x="4613225" y="2665065"/>
+            <a:ext cx="333375" cy="381000"/>
+          </a:xfrm>
+          <a:prstGeom prst="rect">
+            <a:avLst/>
+          </a:prstGeom>
+        </p:spPr>
+      </p:pic>
+      <p:pic>
+        <p:nvPicPr>
+          <p:cNvPr id="15" name="Picture 14" descr="image.png"/>
+          <p:cNvPicPr>
+            <a:picLocks noChangeAspect="1"/>
+          </p:cNvPicPr>
+          <p:nvPr/>
+        </p:nvPicPr>
+        <p:blipFill>
+          <a:blip r:embed="rId9"/>
+          <a:stretch>
+            <a:fillRect/>
+          </a:stretch>
+        </p:blipFill>
+        <p:spPr>
+          <a:xfrm>
+            <a:off x="8359675" y="2665065"/>
+            <a:ext cx="476250" cy="381000"/>
+          </a:xfrm>
+          <a:prstGeom prst="rect">
+            <a:avLst/>
+          </a:prstGeom>
+        </p:spPr>
+      </p:pic>
+      <p:sp>
+        <p:nvSpPr>
+          <p:cNvPr id="16" name="TextBox 15"/>
+          <p:cNvSpPr txBox="1"/>
+          <p:nvPr/>
+        </p:nvSpPr>
+        <p:spPr>
+          <a:xfrm>
+            <a:off x="571500" y="571500"/>
+            <a:ext cx="11601450" cy="476250"/>
+          </a:xfrm>
+          <a:prstGeom prst="rect">
+            <a:avLst/>
+          </a:prstGeom>
+          <a:noFill/>
+        </p:spPr>
+        <p:txBody>
+          <a:bodyPr wrap="square" lIns="0" tIns="0" rIns="0" bIns="0" anchor="t">
+            <a:spAutoFit/>
+          </a:bodyPr>
+          <a:lstStyle/>
+          <a:p>
+            <a:pPr algn="l">
+              <a:lnSpc>
+                <a:spcPts val="3600"/>
+              </a:lnSpc>
+            </a:pPr>
+            <a:r>
+              <a:rPr sz="3000" b="1" i="0" u="none">
+                <a:solidFill>
+                  <a:srgbClr val="F8FAFC"/>
+                </a:solidFill>
+                <a:latin typeface="Montserrat"/>
+              </a:rPr>
+              <a:t>Mirando al Futuro: Conclusiones y Próximos Pasos</a:t>
+            </a:r>
+          </a:p>
+        </p:txBody>
+      </p:sp>
+      <p:sp>
+        <p:nvSpPr>
+          <p:cNvPr id="17" name="Rectangle 16"/>
+          <p:cNvSpPr/>
+          <p:nvPr/>
+        </p:nvSpPr>
+        <p:spPr>
+          <a:xfrm>
+            <a:off x="571500" y="1123950"/>
+            <a:ext cx="11049000" cy="19050"/>
+          </a:xfrm>
+          <a:prstGeom prst="rect">
+            <a:avLst/>
+          </a:prstGeom>
+          <a:solidFill>
+            <a:srgbClr val="3B82F6"/>
+          </a:solidFill>
+          <a:ln>
+            <a:noFill/>
+          </a:ln>
+          <a:effectLst/>
+        </p:spPr>
+        <p:style>
+          <a:lnRef idx="1">
+            <a:schemeClr val="accent1"/>
+          </a:lnRef>
+          <a:fillRef idx="3">
+            <a:schemeClr val="accent1"/>
+          </a:fillRef>
+          <a:effectRef idx="2">
+            <a:schemeClr val="accent1"/>
+          </a:effectRef>
+          <a:fontRef idx="minor">
+            <a:schemeClr val="lt1"/>
+          </a:fontRef>
+        </p:style>
+        <p:txBody>
+          <a:bodyPr rtlCol="0" anchor="ctr"/>
+          <a:lstStyle/>
+          <a:p>
+            <a:pPr algn="ctr"/>
+            <a:endParaRPr/>
+          </a:p>
+        </p:txBody>
+      </p:sp>
+      <p:sp>
+        <p:nvSpPr>
+          <p:cNvPr id="18" name="TextBox 17"/>
+          <p:cNvSpPr txBox="1"/>
+          <p:nvPr/>
+        </p:nvSpPr>
+        <p:spPr>
+          <a:xfrm>
+            <a:off x="571500" y="1238250"/>
+            <a:ext cx="5981700" cy="319980"/>
+          </a:xfrm>
+          <a:prstGeom prst="rect">
+            <a:avLst/>
+          </a:prstGeom>
+          <a:noFill/>
+        </p:spPr>
+        <p:txBody>
+          <a:bodyPr wrap="square" lIns="0" tIns="0" rIns="0" bIns="0" anchor="t">
+            <a:spAutoFit/>
+          </a:bodyPr>
+          <a:lstStyle/>
+          <a:p>
+            <a:pPr algn="l">
+              <a:lnSpc>
+                <a:spcPts val="2520"/>
+              </a:lnSpc>
+            </a:pPr>
+            <a:r>
+              <a:rPr sz="1800" b="0" i="0" u="none">
+                <a:solidFill>
+                  <a:srgbClr val="94A3B8"/>
+                </a:solidFill>
+                <a:latin typeface="Open Sans"/>
+              </a:rPr>
+              <a:t>Hacia dónde debe evolucionar este ecosistema de datos.</a:t>
+            </a:r>
+          </a:p>
+        </p:txBody>
+      </p:sp>
+    </p:spTree>
+  </p:cSld>
+  <p:clrMapOvr>
+    <a:masterClrMapping/>
+  </p:clrMapOvr>
+</p:sld>
+</file>
+
+<file path=ppt/slides/slide12.xml><?xml version="1.0" encoding="utf-8"?>
 <p:sld xmlns:a="http://schemas.openxmlformats.org/drawingml/2006/main" xmlns:r="http://schemas.openxmlformats.org/officeDocument/2006/relationships" xmlns:p="http://schemas.openxmlformats.org/presentationml/2006/main">
   <p:cSld>
     <p:bg>

</xml_diff>